<commit_message>
Refactor project structure: isolate academic_review from interface_app and upgrade clinical web interface
</commit_message>
<xml_diff>
--- a/slides/Fetal_Health_Classification_Presentation.pptx
+++ b/slides/Fetal_Health_Classification_Presentation.pptx
@@ -15,6 +15,7 @@
     <p:sldId id="263" r:id="rId14"/>
     <p:sldId id="264" r:id="rId15"/>
     <p:sldId id="265" r:id="rId16"/>
+    <p:sldId id="266" r:id="rId17"/>
   </p:sldIdLst>
   <p:sldSz cx="12191695" cy="6858000" type="screen4x3"/>
   <p:notesSz cx="6858000" cy="9144000"/>
@@ -3540,6 +3541,679 @@
             <a:avLst/>
           </a:prstGeom>
           <a:solidFill>
+            <a:srgbClr val="F8FAFC"/>
+          </a:solidFill>
+          <a:ln>
+            <a:noFill/>
+          </a:ln>
+        </p:spPr>
+        <p:style>
+          <a:lnRef idx="1">
+            <a:schemeClr val="accent1"/>
+          </a:lnRef>
+          <a:fillRef idx="3">
+            <a:schemeClr val="accent1"/>
+          </a:fillRef>
+          <a:effectRef idx="2">
+            <a:schemeClr val="accent1"/>
+          </a:effectRef>
+          <a:fontRef idx="minor">
+            <a:schemeClr val="lt1"/>
+          </a:fontRef>
+        </p:style>
+        <p:txBody>
+          <a:bodyPr rtlCol="0" anchor="ctr"/>
+          <a:lstStyle/>
+          <a:p>
+            <a:pPr algn="ctr"/>
+          </a:p>
+        </p:txBody>
+      </p:sp>
+      <p:sp>
+        <p:nvSpPr>
+          <p:cNvPr id="3" name="Rectangle 2"/>
+          <p:cNvSpPr/>
+          <p:nvPr/>
+        </p:nvSpPr>
+        <p:spPr>
+          <a:xfrm>
+            <a:off x="0" y="0"/>
+            <a:ext cx="12191695" cy="91440"/>
+          </a:xfrm>
+          <a:prstGeom prst="rect">
+            <a:avLst/>
+          </a:prstGeom>
+          <a:solidFill>
+            <a:srgbClr val="2563EB"/>
+          </a:solidFill>
+          <a:ln>
+            <a:noFill/>
+          </a:ln>
+        </p:spPr>
+        <p:style>
+          <a:lnRef idx="1">
+            <a:schemeClr val="accent1"/>
+          </a:lnRef>
+          <a:fillRef idx="3">
+            <a:schemeClr val="accent1"/>
+          </a:fillRef>
+          <a:effectRef idx="2">
+            <a:schemeClr val="accent1"/>
+          </a:effectRef>
+          <a:fontRef idx="minor">
+            <a:schemeClr val="lt1"/>
+          </a:fontRef>
+        </p:style>
+        <p:txBody>
+          <a:bodyPr rtlCol="0" anchor="ctr"/>
+          <a:lstStyle/>
+          <a:p>
+            <a:pPr algn="ctr"/>
+          </a:p>
+        </p:txBody>
+      </p:sp>
+      <p:sp>
+        <p:nvSpPr>
+          <p:cNvPr id="4" name="TextBox 3"/>
+          <p:cNvSpPr txBox="1"/>
+          <p:nvPr/>
+        </p:nvSpPr>
+        <p:spPr>
+          <a:xfrm>
+            <a:off x="731520" y="365760"/>
+            <a:ext cx="9144000" cy="320040"/>
+          </a:xfrm>
+          <a:prstGeom prst="rect">
+            <a:avLst/>
+          </a:prstGeom>
+          <a:noFill/>
+        </p:spPr>
+        <p:txBody>
+          <a:bodyPr wrap="square" lIns="0" rIns="0" tIns="0" bIns="0">
+            <a:spAutoFit/>
+          </a:bodyPr>
+          <a:lstStyle/>
+          <a:p>
+            <a:pPr>
+              <a:defRPr sz="1000" b="1">
+                <a:solidFill>
+                  <a:srgbClr val="2563EB"/>
+                </a:solidFill>
+                <a:latin typeface="Calibri"/>
+              </a:defRPr>
+            </a:pPr>
+            <a:r>
+              <a:t>09 • CLINICAL APPLICATION</a:t>
+            </a:r>
+          </a:p>
+        </p:txBody>
+      </p:sp>
+      <p:sp>
+        <p:nvSpPr>
+          <p:cNvPr id="5" name="TextBox 4"/>
+          <p:cNvSpPr txBox="1"/>
+          <p:nvPr/>
+        </p:nvSpPr>
+        <p:spPr>
+          <a:xfrm>
+            <a:off x="731520" y="658368"/>
+            <a:ext cx="10515600" cy="640080"/>
+          </a:xfrm>
+          <a:prstGeom prst="rect">
+            <a:avLst/>
+          </a:prstGeom>
+          <a:noFill/>
+        </p:spPr>
+        <p:txBody>
+          <a:bodyPr wrap="square" lIns="0" rIns="0" tIns="0" bIns="0">
+            <a:spAutoFit/>
+          </a:bodyPr>
+          <a:lstStyle/>
+          <a:p>
+            <a:pPr>
+              <a:defRPr sz="2200" b="1">
+                <a:solidFill>
+                  <a:srgbClr val="0F2C59"/>
+                </a:solidFill>
+                <a:latin typeface="Calibri"/>
+              </a:defRPr>
+            </a:pPr>
+            <a:r>
+              <a:t>Clinical Decision Support &amp; Interactive Web Prototype</a:t>
+            </a:r>
+          </a:p>
+        </p:txBody>
+      </p:sp>
+      <p:sp>
+        <p:nvSpPr>
+          <p:cNvPr id="6" name="TextBox 5"/>
+          <p:cNvSpPr txBox="1"/>
+          <p:nvPr/>
+        </p:nvSpPr>
+        <p:spPr>
+          <a:xfrm>
+            <a:off x="731520" y="6446520"/>
+            <a:ext cx="10698480" cy="274320"/>
+          </a:xfrm>
+          <a:prstGeom prst="rect">
+            <a:avLst/>
+          </a:prstGeom>
+          <a:noFill/>
+        </p:spPr>
+        <p:txBody>
+          <a:bodyPr wrap="none" lIns="0" rIns="0" tIns="0" bIns="0">
+            <a:spAutoFit/>
+          </a:bodyPr>
+          <a:lstStyle/>
+          <a:p>
+            <a:pPr>
+              <a:defRPr sz="900">
+                <a:solidFill>
+                  <a:srgbClr val="64748B"/>
+                </a:solidFill>
+                <a:latin typeface="Calibri"/>
+              </a:defRPr>
+            </a:pPr>
+            <a:r>
+              <a:t>Multiclass Classification of Fetal Health using Cardiotocogram Data • PES University</a:t>
+            </a:r>
+          </a:p>
+        </p:txBody>
+      </p:sp>
+      <p:sp>
+        <p:nvSpPr>
+          <p:cNvPr id="7" name="Rounded Rectangle 6"/>
+          <p:cNvSpPr/>
+          <p:nvPr/>
+        </p:nvSpPr>
+        <p:spPr>
+          <a:xfrm>
+            <a:off x="731520" y="1371600"/>
+            <a:ext cx="3474720" cy="1828800"/>
+          </a:xfrm>
+          <a:prstGeom prst="roundRect">
+            <a:avLst/>
+          </a:prstGeom>
+          <a:solidFill>
+            <a:srgbClr val="FFFFFF"/>
+          </a:solidFill>
+          <a:ln w="12700">
+            <a:solidFill>
+              <a:srgbClr val="E2E8F0"/>
+            </a:solidFill>
+          </a:ln>
+        </p:spPr>
+        <p:style>
+          <a:lnRef idx="1">
+            <a:schemeClr val="accent1"/>
+          </a:lnRef>
+          <a:fillRef idx="3">
+            <a:schemeClr val="accent1"/>
+          </a:fillRef>
+          <a:effectRef idx="2">
+            <a:schemeClr val="accent1"/>
+          </a:effectRef>
+          <a:fontRef idx="minor">
+            <a:schemeClr val="lt1"/>
+          </a:fontRef>
+        </p:style>
+        <p:txBody>
+          <a:bodyPr rtlCol="0" anchor="ctr"/>
+          <a:lstStyle/>
+          <a:p>
+            <a:pPr algn="ctr"/>
+          </a:p>
+        </p:txBody>
+      </p:sp>
+      <p:sp>
+        <p:nvSpPr>
+          <p:cNvPr id="8" name="TextBox 7"/>
+          <p:cNvSpPr txBox="1"/>
+          <p:nvPr/>
+        </p:nvSpPr>
+        <p:spPr>
+          <a:xfrm>
+            <a:off x="914400" y="1508760"/>
+            <a:ext cx="3108960" cy="1554480"/>
+          </a:xfrm>
+          <a:prstGeom prst="rect">
+            <a:avLst/>
+          </a:prstGeom>
+          <a:noFill/>
+        </p:spPr>
+        <p:txBody>
+          <a:bodyPr wrap="square">
+            <a:spAutoFit/>
+          </a:bodyPr>
+          <a:lstStyle/>
+          <a:p>
+            <a:pPr>
+              <a:defRPr b="1" sz="1000">
+                <a:solidFill>
+                  <a:srgbClr val="2563EB"/>
+                </a:solidFill>
+              </a:defRPr>
+            </a:pPr>
+            <a:r>
+              <a:t>FIGO REFERENCE STANDARDS</a:t>
+            </a:r>
+          </a:p>
+          <a:p>
+            <a:pPr>
+              <a:defRPr b="1" sz="1300">
+                <a:solidFill>
+                  <a:srgbClr val="0F2C59"/>
+                </a:solidFill>
+              </a:defRPr>
+            </a:pPr>
+            <a:r>
+              <a:t>Top-Corner Clinical Help Center</a:t>
+            </a:r>
+          </a:p>
+          <a:p>
+            <a:pPr>
+              <a:defRPr sz="1000">
+                <a:solidFill>
+                  <a:srgbClr val="1E293B"/>
+                </a:solidFill>
+              </a:defRPr>
+            </a:pPr>
+            <a:r>
+              <a:t>Integrated guide detailing Baseline FHR (110–160 bpm), Tachycardia (&gt;160), Bradycardia (&lt;110), decelerations &amp; variability.</a:t>
+            </a:r>
+          </a:p>
+        </p:txBody>
+      </p:sp>
+      <p:sp>
+        <p:nvSpPr>
+          <p:cNvPr id="9" name="Rounded Rectangle 8"/>
+          <p:cNvSpPr/>
+          <p:nvPr/>
+        </p:nvSpPr>
+        <p:spPr>
+          <a:xfrm>
+            <a:off x="4343400" y="1371600"/>
+            <a:ext cx="3474720" cy="1828800"/>
+          </a:xfrm>
+          <a:prstGeom prst="roundRect">
+            <a:avLst/>
+          </a:prstGeom>
+          <a:solidFill>
+            <a:srgbClr val="FFFFFF"/>
+          </a:solidFill>
+          <a:ln w="12700">
+            <a:solidFill>
+              <a:srgbClr val="E2E8F0"/>
+            </a:solidFill>
+          </a:ln>
+        </p:spPr>
+        <p:style>
+          <a:lnRef idx="1">
+            <a:schemeClr val="accent1"/>
+          </a:lnRef>
+          <a:fillRef idx="3">
+            <a:schemeClr val="accent1"/>
+          </a:fillRef>
+          <a:effectRef idx="2">
+            <a:schemeClr val="accent1"/>
+          </a:effectRef>
+          <a:fontRef idx="minor">
+            <a:schemeClr val="lt1"/>
+          </a:fontRef>
+        </p:style>
+        <p:txBody>
+          <a:bodyPr rtlCol="0" anchor="ctr"/>
+          <a:lstStyle/>
+          <a:p>
+            <a:pPr algn="ctr"/>
+          </a:p>
+        </p:txBody>
+      </p:sp>
+      <p:sp>
+        <p:nvSpPr>
+          <p:cNvPr id="10" name="TextBox 9"/>
+          <p:cNvSpPr txBox="1"/>
+          <p:nvPr/>
+        </p:nvSpPr>
+        <p:spPr>
+          <a:xfrm>
+            <a:off x="4526280" y="1508760"/>
+            <a:ext cx="3108960" cy="1554480"/>
+          </a:xfrm>
+          <a:prstGeom prst="rect">
+            <a:avLst/>
+          </a:prstGeom>
+          <a:noFill/>
+        </p:spPr>
+        <p:txBody>
+          <a:bodyPr wrap="square">
+            <a:spAutoFit/>
+          </a:bodyPr>
+          <a:lstStyle/>
+          <a:p>
+            <a:pPr>
+              <a:defRPr b="1" sz="1000">
+                <a:solidFill>
+                  <a:srgbClr val="2563EB"/>
+                </a:solidFill>
+              </a:defRPr>
+            </a:pPr>
+            <a:r>
+              <a:t>INSTANT DEMONSTRATION</a:t>
+            </a:r>
+          </a:p>
+          <a:p>
+            <a:pPr>
+              <a:defRPr b="1" sz="1300">
+                <a:solidFill>
+                  <a:srgbClr val="0F2C59"/>
+                </a:solidFill>
+              </a:defRPr>
+            </a:pPr>
+            <a:r>
+              <a:t>1-Click Clinical Presets</a:t>
+            </a:r>
+          </a:p>
+          <a:p>
+            <a:pPr>
+              <a:defRPr sz="1000">
+                <a:solidFill>
+                  <a:srgbClr val="1E293B"/>
+                </a:solidFill>
+              </a:defRPr>
+            </a:pPr>
+            <a:r>
+              <a:t>Pre-loaded profiles for Normal, Suspect, and Pathological cases enabling immediate live validation without manual data entry.</a:t>
+            </a:r>
+          </a:p>
+        </p:txBody>
+      </p:sp>
+      <p:sp>
+        <p:nvSpPr>
+          <p:cNvPr id="11" name="Rounded Rectangle 10"/>
+          <p:cNvSpPr/>
+          <p:nvPr/>
+        </p:nvSpPr>
+        <p:spPr>
+          <a:xfrm>
+            <a:off x="7955280" y="1371600"/>
+            <a:ext cx="3474720" cy="1828800"/>
+          </a:xfrm>
+          <a:prstGeom prst="roundRect">
+            <a:avLst/>
+          </a:prstGeom>
+          <a:solidFill>
+            <a:srgbClr val="FFFFFF"/>
+          </a:solidFill>
+          <a:ln w="12700">
+            <a:solidFill>
+              <a:srgbClr val="E2E8F0"/>
+            </a:solidFill>
+          </a:ln>
+        </p:spPr>
+        <p:style>
+          <a:lnRef idx="1">
+            <a:schemeClr val="accent1"/>
+          </a:lnRef>
+          <a:fillRef idx="3">
+            <a:schemeClr val="accent1"/>
+          </a:fillRef>
+          <a:effectRef idx="2">
+            <a:schemeClr val="accent1"/>
+          </a:effectRef>
+          <a:fontRef idx="minor">
+            <a:schemeClr val="lt1"/>
+          </a:fontRef>
+        </p:style>
+        <p:txBody>
+          <a:bodyPr rtlCol="0" anchor="ctr"/>
+          <a:lstStyle/>
+          <a:p>
+            <a:pPr algn="ctr"/>
+          </a:p>
+        </p:txBody>
+      </p:sp>
+      <p:sp>
+        <p:nvSpPr>
+          <p:cNvPr id="12" name="TextBox 11"/>
+          <p:cNvSpPr txBox="1"/>
+          <p:nvPr/>
+        </p:nvSpPr>
+        <p:spPr>
+          <a:xfrm>
+            <a:off x="8138160" y="1508760"/>
+            <a:ext cx="3108960" cy="1554480"/>
+          </a:xfrm>
+          <a:prstGeom prst="rect">
+            <a:avLst/>
+          </a:prstGeom>
+          <a:noFill/>
+        </p:spPr>
+        <p:txBody>
+          <a:bodyPr wrap="square">
+            <a:spAutoFit/>
+          </a:bodyPr>
+          <a:lstStyle/>
+          <a:p>
+            <a:pPr>
+              <a:defRPr b="1" sz="1000">
+                <a:solidFill>
+                  <a:srgbClr val="2563EB"/>
+                </a:solidFill>
+              </a:defRPr>
+            </a:pPr>
+            <a:r>
+              <a:t>SYNERGISTIC MODELING</a:t>
+            </a:r>
+          </a:p>
+          <a:p>
+            <a:pPr>
+              <a:defRPr b="1" sz="1300">
+                <a:solidFill>
+                  <a:srgbClr val="0F2C59"/>
+                </a:solidFill>
+              </a:defRPr>
+            </a:pPr>
+            <a:r>
+              <a:t>Dual-Engine Architecture</a:t>
+            </a:r>
+          </a:p>
+          <a:p>
+            <a:pPr>
+              <a:defRPr sz="1000">
+                <a:solidFill>
+                  <a:srgbClr val="1E293B"/>
+                </a:solidFill>
+              </a:defRPr>
+            </a:pPr>
+            <a:r>
+              <a:t>Allows toggling between LightGBM (95.89%), XGBoost (95.27%), or running a blended consensus ensemble.</a:t>
+            </a:r>
+          </a:p>
+        </p:txBody>
+      </p:sp>
+      <p:sp>
+        <p:nvSpPr>
+          <p:cNvPr id="13" name="Rounded Rectangle 12"/>
+          <p:cNvSpPr/>
+          <p:nvPr/>
+        </p:nvSpPr>
+        <p:spPr>
+          <a:xfrm>
+            <a:off x="731520" y="3429000"/>
+            <a:ext cx="10698480" cy="2834640"/>
+          </a:xfrm>
+          <a:prstGeom prst="roundRect">
+            <a:avLst/>
+          </a:prstGeom>
+          <a:solidFill>
+            <a:srgbClr val="FFFFFF"/>
+          </a:solidFill>
+          <a:ln w="12700">
+            <a:solidFill>
+              <a:srgbClr val="E2E8F0"/>
+            </a:solidFill>
+          </a:ln>
+        </p:spPr>
+        <p:style>
+          <a:lnRef idx="1">
+            <a:schemeClr val="accent1"/>
+          </a:lnRef>
+          <a:fillRef idx="3">
+            <a:schemeClr val="accent1"/>
+          </a:fillRef>
+          <a:effectRef idx="2">
+            <a:schemeClr val="accent1"/>
+          </a:effectRef>
+          <a:fontRef idx="minor">
+            <a:schemeClr val="lt1"/>
+          </a:fontRef>
+        </p:style>
+        <p:txBody>
+          <a:bodyPr rtlCol="0" anchor="ctr"/>
+          <a:lstStyle/>
+          <a:p>
+            <a:pPr algn="ctr"/>
+          </a:p>
+        </p:txBody>
+      </p:sp>
+      <p:sp>
+        <p:nvSpPr>
+          <p:cNvPr id="14" name="TextBox 13"/>
+          <p:cNvSpPr txBox="1"/>
+          <p:nvPr/>
+        </p:nvSpPr>
+        <p:spPr>
+          <a:xfrm>
+            <a:off x="1005840" y="3611880"/>
+            <a:ext cx="10149840" cy="2468880"/>
+          </a:xfrm>
+          <a:prstGeom prst="rect">
+            <a:avLst/>
+          </a:prstGeom>
+          <a:noFill/>
+        </p:spPr>
+        <p:txBody>
+          <a:bodyPr wrap="square">
+            <a:spAutoFit/>
+          </a:bodyPr>
+          <a:lstStyle/>
+          <a:p>
+            <a:pPr>
+              <a:defRPr b="1" sz="1500">
+                <a:solidFill>
+                  <a:srgbClr val="0F2C59"/>
+                </a:solidFill>
+              </a:defRPr>
+            </a:pPr>
+            <a:r>
+              <a:t>Real-Time Triage Engine &amp; Obstetric Action Protocols</a:t>
+            </a:r>
+          </a:p>
+          <a:p>
+            <a:pPr>
+              <a:spcBef>
+                <a:spcPts val="600"/>
+              </a:spcBef>
+            </a:pPr>
+            <a:r>
+              <a:rPr sz="1100">
+                <a:solidFill>
+                  <a:srgbClr val="1E3A8A"/>
+                </a:solidFill>
+              </a:rPr>
+              <a:t>• Actionable Triage Recommendations: </a:t>
+            </a:r>
+            <a:r>
+              <a:rPr sz="1050">
+                <a:solidFill>
+                  <a:srgbClr val="1E293B"/>
+                </a:solidFill>
+              </a:rPr>
+              <a:t>Rather than raw probabilities, the app returns clinical directives: Class 1 (Routine Antenatal Care), Class 2 (Elevated Surveillance, Repositioning &amp; Re-evaluate in 30 min), Class 3 (CRITICAL ALERT: Emergency obstetrician bedside review).</a:t>
+            </a:r>
+          </a:p>
+          <a:p>
+            <a:pPr>
+              <a:spcBef>
+                <a:spcPts val="600"/>
+              </a:spcBef>
+            </a:pPr>
+            <a:r>
+              <a:rPr sz="1100">
+                <a:solidFill>
+                  <a:srgbClr val="1E3A8A"/>
+                </a:solidFill>
+              </a:rPr>
+              <a:t>• Biomarker Anomaly Flags: </a:t>
+            </a:r>
+            <a:r>
+              <a:rPr sz="1050">
+                <a:solidFill>
+                  <a:srgbClr val="1E293B"/>
+                </a:solidFill>
+              </a:rPr>
+              <a:t>Automatically detects and flags inputs that breach safe medical thresholds (e.g., baseline heart rate &gt;160 bpm, prolonged decelerations &gt;0 / sec, abnormal variability &gt;50%).</a:t>
+            </a:r>
+          </a:p>
+          <a:p>
+            <a:pPr>
+              <a:spcBef>
+                <a:spcPts val="600"/>
+              </a:spcBef>
+            </a:pPr>
+            <a:r>
+              <a:rPr sz="1100">
+                <a:solidFill>
+                  <a:srgbClr val="1E3A8A"/>
+                </a:solidFill>
+              </a:rPr>
+              <a:t>• Modular Clean Architecture: </a:t>
+            </a:r>
+            <a:r>
+              <a:rPr sz="1050">
+                <a:solidFill>
+                  <a:srgbClr val="1E293B"/>
+                </a:solidFill>
+              </a:rPr>
+              <a:t>Entire application isolated in `interface_app/` with dedicated model pipelines, separated cleanly from the core machine learning benchmarks in `academic_review/`.</a:t>
+            </a:r>
+          </a:p>
+        </p:txBody>
+      </p:sp>
+    </p:spTree>
+  </p:cSld>
+  <p:clrMapOvr>
+    <a:masterClrMapping/>
+  </p:clrMapOvr>
+</p:sld>
+</file>
+
+<file path=ppt/slides/slide11.xml><?xml version="1.0" encoding="utf-8"?>
+<p:sld xmlns:a="http://schemas.openxmlformats.org/drawingml/2006/main" xmlns:p="http://schemas.openxmlformats.org/presentationml/2006/main" xmlns:r="http://schemas.openxmlformats.org/officeDocument/2006/relationships">
+  <p:cSld>
+    <p:spTree>
+      <p:nvGrpSpPr>
+        <p:cNvPr id="1" name=""/>
+        <p:cNvGrpSpPr/>
+        <p:nvPr/>
+      </p:nvGrpSpPr>
+      <p:grpSpPr/>
+      <p:sp>
+        <p:nvSpPr>
+          <p:cNvPr id="2" name="Rectangle 1"/>
+          <p:cNvSpPr/>
+          <p:nvPr/>
+        </p:nvSpPr>
+        <p:spPr>
+          <a:xfrm>
+            <a:off x="0" y="0"/>
+            <a:ext cx="12191695" cy="6858000"/>
+          </a:xfrm>
+          <a:prstGeom prst="rect">
+            <a:avLst/>
+          </a:prstGeom>
+          <a:solidFill>
             <a:srgbClr val="0F2C59"/>
           </a:solidFill>
           <a:ln>
@@ -3628,23 +4302,19 @@
               </a:defRPr>
             </a:pPr>
             <a:r>
-              <a:t>Ready for live execution walkthrough of code repository:</a:t>
+              <a:t>Structured Repository Ready for Live Execution Walkthrough:</a:t>
             </a:r>
             <a:br/>
             <a:r>
-              <a:t>• 01_EDA.py (Feature distributions &amp; SelectKBest rankings)</a:t>
+              <a:t>• Academic Evaluation: academic_review/scripts/03_benchmark_all_10_models.py</a:t>
             </a:r>
             <a:br/>
             <a:r>
-              <a:t>• 02_preprocessing.py (StandardScaler &amp; 70/30 stratified train-test splits)</a:t>
+              <a:t>• Interactive Clinical App: streamlit run interface_app/app.py</a:t>
             </a:r>
             <a:br/>
             <a:r>
-              <a:t>• 03_models_member1.py (XGBoost, Random Forest, MLP, SVM RBF, Logistic Regression)</a:t>
-            </a:r>
-            <a:br/>
-            <a:r>
-              <a:t>• 04_models_member2.py (LightGBM, Gradient Boosting, Decision Tree, Linear SVM, KNN)</a:t>
+              <a:t>• Formal Deliverables: 2-Page Report (writeup.pdf) &amp; Benchmark Charts</a:t>
             </a:r>
           </a:p>
           <a:p>
@@ -4833,7 +5503,7 @@
         <p:spPr>
           <a:xfrm>
             <a:off x="6675120" y="1600200"/>
-            <a:ext cx="4572000" cy="3429000"/>
+            <a:ext cx="4572000" cy="3265714"/>
           </a:xfrm>
           <a:prstGeom prst="rect">
             <a:avLst/>
@@ -5165,7 +5835,7 @@
         <p:spPr>
           <a:xfrm>
             <a:off x="914400" y="1554480"/>
-            <a:ext cx="4937760" cy="3950208"/>
+            <a:ext cx="4937760" cy="2962656"/>
           </a:xfrm>
           <a:prstGeom prst="rect">
             <a:avLst/>
@@ -6289,7 +6959,7 @@
         <p:spPr>
           <a:xfrm>
             <a:off x="868680" y="1508760"/>
-            <a:ext cx="5943600" cy="3268980"/>
+            <a:ext cx="5943600" cy="3241964"/>
           </a:xfrm>
           <a:prstGeom prst="rect">
             <a:avLst/>
@@ -6394,7 +7064,7 @@
                   <a:srgbClr val="1E293B"/>
                 </a:solidFill>
               </a:rPr>
-              <a:t>LightGBM (95.89%), XGBoost (95.27%), and Gradient Boosting (95.11%) represent the top tier, matching published Stanford benchmarks.</a:t>
+              <a:t>LightGBM (95.74%), XGBoost (95.27%), and Gradient Boosting (94.79%) represent the top tier, matching published Stanford benchmarks.</a:t>
             </a:r>
           </a:p>
           <a:p>
@@ -6463,7 +7133,7 @@
                   <a:srgbClr val="1E293B"/>
                 </a:solidFill>
               </a:rPr>
-              <a:t>Linear SVM (89.90%) and Logistic Regression (89.43%) establish that the biological CTG decision boundaries are strictly non-linear.</a:t>
+              <a:t>Linear SVM (89.91%) and Logistic Regression (89.43%) establish that the biological CTG decision boundaries are strictly non-linear.</a:t>
             </a:r>
           </a:p>
           <a:p>

</xml_diff>